<commit_message>
Highlights deck: Layanan slide holds 5 services
Co-Authored-By: Claude Opus 5.5 <noreply@anthropic.com>
Claude-Session: https://claude.ai/code/session_0119Ya7X5CAuYAbFrWJFaXf7
</commit_message>
<xml_diff>
--- a/deliverables/launch/highlights/H8KI_Instagram_Highlights_EDITABLE.pptx
+++ b/deliverables/launch/highlights/H8KI_Instagram_Highlights_EDITABLE.pptx
@@ -115,30 +115,30 @@
   <p:extLst>
     <p:ext uri="{521415D9-36F7-43E2-AB2F-B90AF26B5E84}">
       <p14:sectionLst xmlns:p14="http://schemas.microsoft.com/office/powerpoint/2010/main">
-        <p14:section name="Petunjuk" id="{191fd3a9-154a-21cf-176f-e66d58273547}">
+        <p14:section name="Petunjuk" id="{87f9b4c1-f2d4-9dfe-abca-7b20a96f897b}">
           <p14:sldIdLst>
             <p14:sldId id="256"/>
           </p14:sldIdLst>
         </p14:section>
-        <p14:section name="Layanan" id="{cdff5539-0eab-ce5d-a78f-5f88990d8729}">
+        <p14:section name="Layanan" id="{56d8a505-ba0f-712a-543e-68be4ac2a137}">
           <p14:sldIdLst>
             <p14:sldId id="257"/>
             <p14:sldId id="258"/>
           </p14:sldIdLst>
         </p14:section>
-        <p14:section name="Area" id="{41914630-b355-ac17-26c4-0385505a34d2}">
+        <p14:section name="Area" id="{07f90803-80d9-8fad-d975-4d886b6103b5}">
           <p14:sldIdLst>
             <p14:sldId id="259"/>
             <p14:sldId id="260"/>
           </p14:sldIdLst>
         </p14:section>
-        <p14:section name="Cara Order" id="{d5fa3f1e-3ebd-f378-0dc9-8e9eb96d9236}">
+        <p14:section name="Cara Order" id="{cc8bcbc0-0b8a-7402-5a19-2c4749cdcc03}">
           <p14:sldIdLst>
             <p14:sldId id="261"/>
             <p14:sldId id="262"/>
           </p14:sldIdLst>
         </p14:section>
-        <p14:section name="Testimoni" id="{1046f21c-14e1-a0b6-53a8-27141eba2e9d}">
+        <p14:section name="Testimoni" id="{80c626c0-4790-5de3-e529-e21a6161e208}">
           <p14:sldIdLst>
             <p14:sldId id="263"/>
             <p14:sldId id="264"/>
@@ -2667,12 +2667,12 @@
         </p:nvSpPr>
         <p:spPr>
           <a:xfrm>
-            <a:off x="571500" y="6667500"/>
-            <a:ext cx="9144000" cy="2190750"/>
+            <a:off x="571500" y="6438900"/>
+            <a:ext cx="9144000" cy="1390650"/>
           </a:xfrm>
           <a:prstGeom prst="roundRect">
             <a:avLst>
-              <a:gd name="adj" fmla="val 15652"/>
+              <a:gd name="adj" fmla="val 24658"/>
             </a:avLst>
           </a:prstGeom>
           <a:solidFill>
@@ -2696,8 +2696,8 @@
         </p:nvSpPr>
         <p:spPr>
           <a:xfrm>
-            <a:off x="571500" y="6667500"/>
-            <a:ext cx="152400" cy="2190750"/>
+            <a:off x="571500" y="6438900"/>
+            <a:ext cx="152400" cy="1390650"/>
           </a:xfrm>
           <a:prstGeom prst="roundRect">
             <a:avLst>
@@ -2718,8 +2718,8 @@
         </p:nvSpPr>
         <p:spPr>
           <a:xfrm>
-            <a:off x="1143000" y="6896100"/>
-            <a:ext cx="8191500" cy="1733550"/>
+            <a:off x="1143000" y="6591300"/>
+            <a:ext cx="8191500" cy="1085850"/>
           </a:xfrm>
           <a:prstGeom prst="rect">
             <a:avLst/>
@@ -2737,14 +2737,14 @@
               <a:buNone/>
             </a:pPr>
             <a:r>
-              <a:rPr lang="en-US" sz="2850" b="1" dirty="0">
+              <a:rPr lang="en-US" sz="2400" b="1" dirty="0">
                 <a:solidFill>
                   <a:schemeClr val="tx1"/>
                 </a:solidFill>
               </a:rPr>
               <a:t>[ISI: layanan 1, mis. Reguler]</a:t>
             </a:r>
-            <a:endParaRPr lang="en-US" sz="2850" dirty="0"/>
+            <a:endParaRPr lang="en-US" sz="2400" dirty="0"/>
           </a:p>
           <a:p>
             <a:pPr indent="0" marL="0">
@@ -2754,14 +2754,14 @@
               <a:buNone/>
             </a:pPr>
             <a:r>
-              <a:rPr lang="en-US" sz="2250" dirty="0">
+              <a:rPr lang="en-US" sz="1950" dirty="0">
                 <a:solidFill>
                   <a:schemeClr val="tx2"/>
                 </a:solidFill>
               </a:rPr>
               <a:t>[ISI: keterangan &amp; estimasi waktu]</a:t>
             </a:r>
-            <a:endParaRPr lang="en-US" sz="2850" dirty="0"/>
+            <a:endParaRPr lang="en-US" sz="2400" dirty="0"/>
           </a:p>
         </p:txBody>
       </p:sp>
@@ -2773,12 +2773,12 @@
         </p:nvSpPr>
         <p:spPr>
           <a:xfrm>
-            <a:off x="571500" y="9144000"/>
-            <a:ext cx="9144000" cy="2190750"/>
+            <a:off x="571500" y="7981950"/>
+            <a:ext cx="9144000" cy="1390650"/>
           </a:xfrm>
           <a:prstGeom prst="roundRect">
             <a:avLst>
-              <a:gd name="adj" fmla="val 15652"/>
+              <a:gd name="adj" fmla="val 24658"/>
             </a:avLst>
           </a:prstGeom>
           <a:solidFill>
@@ -2802,8 +2802,8 @@
         </p:nvSpPr>
         <p:spPr>
           <a:xfrm>
-            <a:off x="571500" y="9144000"/>
-            <a:ext cx="152400" cy="2190750"/>
+            <a:off x="571500" y="7981950"/>
+            <a:ext cx="152400" cy="1390650"/>
           </a:xfrm>
           <a:prstGeom prst="roundRect">
             <a:avLst>
@@ -2824,8 +2824,8 @@
         </p:nvSpPr>
         <p:spPr>
           <a:xfrm>
-            <a:off x="1143000" y="9372600"/>
-            <a:ext cx="8191500" cy="1733550"/>
+            <a:off x="1143000" y="8134350"/>
+            <a:ext cx="8191500" cy="1085850"/>
           </a:xfrm>
           <a:prstGeom prst="rect">
             <a:avLst/>
@@ -2843,14 +2843,14 @@
               <a:buNone/>
             </a:pPr>
             <a:r>
-              <a:rPr lang="en-US" sz="2850" b="1" dirty="0">
+              <a:rPr lang="en-US" sz="2400" b="1" dirty="0">
                 <a:solidFill>
                   <a:schemeClr val="tx1"/>
                 </a:solidFill>
               </a:rPr>
               <a:t>[ISI: layanan 2, mis. Same Day]</a:t>
             </a:r>
-            <a:endParaRPr lang="en-US" sz="2850" dirty="0"/>
+            <a:endParaRPr lang="en-US" sz="2400" dirty="0"/>
           </a:p>
           <a:p>
             <a:pPr indent="0" marL="0">
@@ -2860,14 +2860,14 @@
               <a:buNone/>
             </a:pPr>
             <a:r>
-              <a:rPr lang="en-US" sz="2250" dirty="0">
+              <a:rPr lang="en-US" sz="1950" dirty="0">
                 <a:solidFill>
                   <a:schemeClr val="tx2"/>
                 </a:solidFill>
               </a:rPr>
               <a:t>[ISI: keterangan &amp; estimasi waktu]</a:t>
             </a:r>
-            <a:endParaRPr lang="en-US" sz="2850" dirty="0"/>
+            <a:endParaRPr lang="en-US" sz="2400" dirty="0"/>
           </a:p>
         </p:txBody>
       </p:sp>
@@ -2879,12 +2879,12 @@
         </p:nvSpPr>
         <p:spPr>
           <a:xfrm>
-            <a:off x="571500" y="11620500"/>
-            <a:ext cx="9144000" cy="2190750"/>
+            <a:off x="571500" y="9525000"/>
+            <a:ext cx="9144000" cy="1390650"/>
           </a:xfrm>
           <a:prstGeom prst="roundRect">
             <a:avLst>
-              <a:gd name="adj" fmla="val 15652"/>
+              <a:gd name="adj" fmla="val 24658"/>
             </a:avLst>
           </a:prstGeom>
           <a:solidFill>
@@ -2908,8 +2908,8 @@
         </p:nvSpPr>
         <p:spPr>
           <a:xfrm>
-            <a:off x="571500" y="11620500"/>
-            <a:ext cx="152400" cy="2190750"/>
+            <a:off x="571500" y="9525000"/>
+            <a:ext cx="152400" cy="1390650"/>
           </a:xfrm>
           <a:prstGeom prst="roundRect">
             <a:avLst>
@@ -2930,8 +2930,8 @@
         </p:nvSpPr>
         <p:spPr>
           <a:xfrm>
-            <a:off x="1143000" y="11849100"/>
-            <a:ext cx="8191500" cy="1733550"/>
+            <a:off x="1143000" y="9677400"/>
+            <a:ext cx="8191500" cy="1085850"/>
           </a:xfrm>
           <a:prstGeom prst="rect">
             <a:avLst/>
@@ -2949,14 +2949,14 @@
               <a:buNone/>
             </a:pPr>
             <a:r>
-              <a:rPr lang="en-US" sz="2850" b="1" dirty="0">
+              <a:rPr lang="en-US" sz="2400" b="1" dirty="0">
                 <a:solidFill>
                   <a:schemeClr val="tx1"/>
                 </a:solidFill>
               </a:rPr>
               <a:t>[ISI: layanan 3, mis. Kargo]</a:t>
             </a:r>
-            <a:endParaRPr lang="en-US" sz="2850" dirty="0"/>
+            <a:endParaRPr lang="en-US" sz="2400" dirty="0"/>
           </a:p>
           <a:p>
             <a:pPr indent="0" marL="0">
@@ -2966,63 +2966,56 @@
               <a:buNone/>
             </a:pPr>
             <a:r>
-              <a:rPr lang="en-US" sz="2250" dirty="0">
+              <a:rPr lang="en-US" sz="1950" dirty="0">
                 <a:solidFill>
                   <a:schemeClr val="tx2"/>
                 </a:solidFill>
               </a:rPr>
-              <a:t>[ISI: keterangan singkat]</a:t>
-            </a:r>
-            <a:endParaRPr lang="en-US" sz="2850" dirty="0"/>
-          </a:p>
-        </p:txBody>
-      </p:sp>
-      <p:sp>
-        <p:nvSpPr>
-          <p:cNvPr id="16" name="Catatan bawah_34"/>
-          <p:cNvSpPr txBox="1"/>
-          <p:nvPr/>
-        </p:nvSpPr>
-        <p:spPr>
-          <a:xfrm>
-            <a:off x="571500" y="14135100"/>
-            <a:ext cx="9144000" cy="533400"/>
-          </a:xfrm>
-          <a:prstGeom prst="rect">
-            <a:avLst/>
-          </a:prstGeom>
-          <a:noFill/>
-          <a:ln/>
-        </p:spPr>
-        <p:txBody>
-          <a:bodyPr wrap="square" lIns="0" tIns="0" rIns="0" bIns="0" rtlCol="0" anchor="ctr"/>
-          <a:lstStyle/>
-          <a:p>
-            <a:pPr algn="ctr" indent="0" marL="0">
-              <a:buNone/>
-            </a:pPr>
-            <a:r>
-              <a:rPr lang="en-US" sz="2250" dirty="0">
-                <a:solidFill>
-                  <a:schemeClr val="tx2"/>
-                </a:solidFill>
-              </a:rPr>
-              <a:t>Alamat cuma pakai patokan? Kurir kami cari sampai ketemu.</a:t>
-            </a:r>
-            <a:endParaRPr lang="en-US" sz="2250" dirty="0"/>
-          </a:p>
-        </p:txBody>
-      </p:sp>
-      <p:sp>
-        <p:nvSpPr>
-          <p:cNvPr id="17" name="Tombol WhatsApp_35"/>
+              <a:t>[ISI: keterangan &amp; estimasi waktu]</a:t>
+            </a:r>
+            <a:endParaRPr lang="en-US" sz="2400" dirty="0"/>
+          </a:p>
+        </p:txBody>
+      </p:sp>
+      <p:sp>
+        <p:nvSpPr>
+          <p:cNvPr id="16" name="Kartu_34"/>
           <p:cNvSpPr/>
           <p:nvPr/>
         </p:nvSpPr>
         <p:spPr>
           <a:xfrm>
-            <a:off x="1047750" y="14859000"/>
-            <a:ext cx="8191500" cy="857250"/>
+            <a:off x="571500" y="11068050"/>
+            <a:ext cx="9144000" cy="1390650"/>
+          </a:xfrm>
+          <a:prstGeom prst="roundRect">
+            <a:avLst>
+              <a:gd name="adj" fmla="val 24658"/>
+            </a:avLst>
+          </a:prstGeom>
+          <a:solidFill>
+            <a:schemeClr val="bg1"/>
+          </a:solidFill>
+          <a:ln/>
+          <a:effectLst>
+            <a:outerShdw sx="100000" sy="100000" kx="0" ky="0" algn="bl" rotWithShape="0" blurRad="177800" dist="76200" dir="5400000">
+              <a:srgbClr val="000000">
+                <a:alpha val="18000"/>
+              </a:srgbClr>
+            </a:outerShdw>
+          </a:effectLst>
+        </p:spPr>
+      </p:sp>
+      <p:sp>
+        <p:nvSpPr>
+          <p:cNvPr id="17" name="Penanda kartu_35"/>
+          <p:cNvSpPr/>
+          <p:nvPr/>
+        </p:nvSpPr>
+        <p:spPr>
+          <a:xfrm>
+            <a:off x="571500" y="11068050"/>
+            <a:ext cx="152400" cy="1390650"/>
           </a:xfrm>
           <a:prstGeom prst="roundRect">
             <a:avLst>
@@ -3030,6 +3023,225 @@
             </a:avLst>
           </a:prstGeom>
           <a:solidFill>
+            <a:schemeClr val="accent1"/>
+          </a:solidFill>
+          <a:ln/>
+        </p:spPr>
+      </p:sp>
+      <p:sp>
+        <p:nvSpPr>
+          <p:cNvPr id="18" name="Isi kartu 4_36"/>
+          <p:cNvSpPr txBox="1"/>
+          <p:nvPr/>
+        </p:nvSpPr>
+        <p:spPr>
+          <a:xfrm>
+            <a:off x="1143000" y="11220450"/>
+            <a:ext cx="8191500" cy="1085850"/>
+          </a:xfrm>
+          <a:prstGeom prst="rect">
+            <a:avLst/>
+          </a:prstGeom>
+          <a:noFill/>
+          <a:ln/>
+        </p:spPr>
+        <p:txBody>
+          <a:bodyPr wrap="square" lIns="0" tIns="0" rIns="0" bIns="0" rtlCol="0" anchor="ctr">
+            <a:normAutofit/>
+          </a:bodyPr>
+          <a:lstStyle/>
+          <a:p>
+            <a:pPr indent="0" marL="0">
+              <a:buNone/>
+            </a:pPr>
+            <a:r>
+              <a:rPr lang="en-US" sz="2400" b="1" dirty="0">
+                <a:solidFill>
+                  <a:schemeClr val="tx1"/>
+                </a:solidFill>
+              </a:rPr>
+              <a:t>[ISI: layanan 4]</a:t>
+            </a:r>
+            <a:endParaRPr lang="en-US" sz="2400" dirty="0"/>
+          </a:p>
+          <a:p>
+            <a:pPr indent="0" marL="0">
+              <a:spcBef>
+                <a:spcPts val="600"/>
+              </a:spcBef>
+              <a:buNone/>
+            </a:pPr>
+            <a:r>
+              <a:rPr lang="en-US" sz="1950" dirty="0">
+                <a:solidFill>
+                  <a:schemeClr val="tx2"/>
+                </a:solidFill>
+              </a:rPr>
+              <a:t>[ISI: keterangan &amp; estimasi waktu]</a:t>
+            </a:r>
+            <a:endParaRPr lang="en-US" sz="2400" dirty="0"/>
+          </a:p>
+        </p:txBody>
+      </p:sp>
+      <p:sp>
+        <p:nvSpPr>
+          <p:cNvPr id="19" name="Kartu_37"/>
+          <p:cNvSpPr/>
+          <p:nvPr/>
+        </p:nvSpPr>
+        <p:spPr>
+          <a:xfrm>
+            <a:off x="571500" y="12611100"/>
+            <a:ext cx="9144000" cy="1390650"/>
+          </a:xfrm>
+          <a:prstGeom prst="roundRect">
+            <a:avLst>
+              <a:gd name="adj" fmla="val 24658"/>
+            </a:avLst>
+          </a:prstGeom>
+          <a:solidFill>
+            <a:schemeClr val="bg1"/>
+          </a:solidFill>
+          <a:ln/>
+          <a:effectLst>
+            <a:outerShdw sx="100000" sy="100000" kx="0" ky="0" algn="bl" rotWithShape="0" blurRad="177800" dist="76200" dir="5400000">
+              <a:srgbClr val="000000">
+                <a:alpha val="18000"/>
+              </a:srgbClr>
+            </a:outerShdw>
+          </a:effectLst>
+        </p:spPr>
+      </p:sp>
+      <p:sp>
+        <p:nvSpPr>
+          <p:cNvPr id="20" name="Penanda kartu_38"/>
+          <p:cNvSpPr/>
+          <p:nvPr/>
+        </p:nvSpPr>
+        <p:spPr>
+          <a:xfrm>
+            <a:off x="571500" y="12611100"/>
+            <a:ext cx="152400" cy="1390650"/>
+          </a:xfrm>
+          <a:prstGeom prst="roundRect">
+            <a:avLst>
+              <a:gd name="adj" fmla="val 50000"/>
+            </a:avLst>
+          </a:prstGeom>
+          <a:solidFill>
+            <a:schemeClr val="accent1"/>
+          </a:solidFill>
+          <a:ln/>
+        </p:spPr>
+      </p:sp>
+      <p:sp>
+        <p:nvSpPr>
+          <p:cNvPr id="21" name="Isi kartu 5_39"/>
+          <p:cNvSpPr txBox="1"/>
+          <p:nvPr/>
+        </p:nvSpPr>
+        <p:spPr>
+          <a:xfrm>
+            <a:off x="1143000" y="12763500"/>
+            <a:ext cx="8191500" cy="1085850"/>
+          </a:xfrm>
+          <a:prstGeom prst="rect">
+            <a:avLst/>
+          </a:prstGeom>
+          <a:noFill/>
+          <a:ln/>
+        </p:spPr>
+        <p:txBody>
+          <a:bodyPr wrap="square" lIns="0" tIns="0" rIns="0" bIns="0" rtlCol="0" anchor="ctr">
+            <a:normAutofit/>
+          </a:bodyPr>
+          <a:lstStyle/>
+          <a:p>
+            <a:pPr indent="0" marL="0">
+              <a:buNone/>
+            </a:pPr>
+            <a:r>
+              <a:rPr lang="en-US" sz="2400" b="1" dirty="0">
+                <a:solidFill>
+                  <a:schemeClr val="tx1"/>
+                </a:solidFill>
+              </a:rPr>
+              <a:t>[ISI: layanan 5]</a:t>
+            </a:r>
+            <a:endParaRPr lang="en-US" sz="2400" dirty="0"/>
+          </a:p>
+          <a:p>
+            <a:pPr indent="0" marL="0">
+              <a:spcBef>
+                <a:spcPts val="600"/>
+              </a:spcBef>
+              <a:buNone/>
+            </a:pPr>
+            <a:r>
+              <a:rPr lang="en-US" sz="1950" dirty="0">
+                <a:solidFill>
+                  <a:schemeClr val="tx2"/>
+                </a:solidFill>
+              </a:rPr>
+              <a:t>[ISI: keterangan &amp; estimasi waktu]</a:t>
+            </a:r>
+            <a:endParaRPr lang="en-US" sz="2400" dirty="0"/>
+          </a:p>
+        </p:txBody>
+      </p:sp>
+      <p:sp>
+        <p:nvSpPr>
+          <p:cNvPr id="22" name="Catatan bawah_40"/>
+          <p:cNvSpPr txBox="1"/>
+          <p:nvPr/>
+        </p:nvSpPr>
+        <p:spPr>
+          <a:xfrm>
+            <a:off x="571500" y="14192250"/>
+            <a:ext cx="9144000" cy="533400"/>
+          </a:xfrm>
+          <a:prstGeom prst="rect">
+            <a:avLst/>
+          </a:prstGeom>
+          <a:noFill/>
+          <a:ln/>
+        </p:spPr>
+        <p:txBody>
+          <a:bodyPr wrap="square" lIns="0" tIns="0" rIns="0" bIns="0" rtlCol="0" anchor="ctr"/>
+          <a:lstStyle/>
+          <a:p>
+            <a:pPr algn="ctr" indent="0" marL="0">
+              <a:buNone/>
+            </a:pPr>
+            <a:r>
+              <a:rPr lang="en-US" sz="2250" dirty="0">
+                <a:solidFill>
+                  <a:schemeClr val="tx2"/>
+                </a:solidFill>
+              </a:rPr>
+              <a:t>Alamat cuma pakai patokan? Kurir kami cari sampai ketemu.</a:t>
+            </a:r>
+            <a:endParaRPr lang="en-US" sz="2250" dirty="0"/>
+          </a:p>
+        </p:txBody>
+      </p:sp>
+      <p:sp>
+        <p:nvSpPr>
+          <p:cNvPr id="23" name="Tombol WhatsApp_41"/>
+          <p:cNvSpPr/>
+          <p:nvPr/>
+        </p:nvSpPr>
+        <p:spPr>
+          <a:xfrm>
+            <a:off x="1047750" y="14859000"/>
+            <a:ext cx="8191500" cy="857250"/>
+          </a:xfrm>
+          <a:prstGeom prst="roundRect">
+            <a:avLst>
+              <a:gd name="adj" fmla="val 50000"/>
+            </a:avLst>
+          </a:prstGeom>
+          <a:solidFill>
             <a:schemeClr val="accent2"/>
           </a:solidFill>
           <a:ln/>
@@ -3066,7 +3278,7 @@
       </p:sp>
       <p:sp>
         <p:nvSpPr>
-          <p:cNvPr id="18" name="Catatan (di luar slide, tidak ikut ter-export)"/>
+          <p:cNvPr id="24" name="Catatan (di luar slide, tidak ikut ter-export)"/>
           <p:cNvSpPr txBox="1"/>
           <p:nvPr/>
         </p:nvSpPr>
@@ -3138,7 +3350,7 @@
                   <a:srgbClr val="181C28"/>
                 </a:solidFill>
               </a:rPr>
-              <a:t>nama 3 layanan</a:t>
+              <a:t>nama 5 layanan (1 kartu = 1 layanan)</a:t>
             </a:r>
             <a:endParaRPr lang="en-US" sz="1600" dirty="0"/>
           </a:p>
@@ -3248,7 +3460,7 @@
       </p:grpSpPr>
       <p:pic>
         <p:nvPicPr>
-          <p:cNvPr id="2" name="Ikon_36" descr="Ikon highlight Area">    </p:cNvPr>
+          <p:cNvPr id="2" name="Ikon_42" descr="Ikon highlight Area">    </p:cNvPr>
           <p:cNvPicPr>
             <a:picLocks noChangeAspect="1"/>
           </p:cNvPicPr>
@@ -3393,7 +3605,7 @@
       </p:grpSpPr>
       <p:sp>
         <p:nvSpPr>
-          <p:cNvPr id="2" name="Latar judul_37"/>
+          <p:cNvPr id="2" name="Latar judul_43"/>
           <p:cNvSpPr/>
           <p:nvPr/>
         </p:nvSpPr>
@@ -3413,7 +3625,7 @@
       </p:sp>
       <p:sp>
         <p:nvSpPr>
-          <p:cNvPr id="3" name="Plat logo_38"/>
+          <p:cNvPr id="3" name="Plat logo_44"/>
           <p:cNvSpPr/>
           <p:nvPr/>
         </p:nvSpPr>
@@ -3435,7 +3647,7 @@
       </p:sp>
       <p:pic>
         <p:nvPicPr>
-          <p:cNvPr id="4" name="Logo H8KI_39" descr="Logo H8KI">    </p:cNvPr>
+          <p:cNvPr id="4" name="Logo H8KI_45" descr="Logo H8KI">    </p:cNvPr>
           <p:cNvPicPr>
             <a:picLocks noChangeAspect="1"/>
           </p:cNvPicPr>
@@ -3459,7 +3671,7 @@
       </p:pic>
       <p:sp>
         <p:nvSpPr>
-          <p:cNvPr id="5" name="Subjudul_40"/>
+          <p:cNvPr id="5" name="Subjudul_46"/>
           <p:cNvSpPr txBox="1"/>
           <p:nvPr/>
         </p:nvSpPr>
@@ -3495,7 +3707,7 @@
       </p:sp>
       <p:sp>
         <p:nvSpPr>
-          <p:cNvPr id="6" name="Judul_41"/>
+          <p:cNvPr id="6" name="Judul_47"/>
           <p:cNvSpPr txBox="1"/>
           <p:nvPr/>
         </p:nvSpPr>
@@ -3531,7 +3743,7 @@
       </p:sp>
       <p:sp>
         <p:nvSpPr>
-          <p:cNvPr id="7" name="Kartu_42"/>
+          <p:cNvPr id="7" name="Kartu_48"/>
           <p:cNvSpPr/>
           <p:nvPr/>
         </p:nvSpPr>
@@ -3560,7 +3772,7 @@
       </p:sp>
       <p:sp>
         <p:nvSpPr>
-          <p:cNvPr id="8" name="Penanda kartu_43"/>
+          <p:cNvPr id="8" name="Penanda kartu_49"/>
           <p:cNvSpPr/>
           <p:nvPr/>
         </p:nvSpPr>
@@ -3582,7 +3794,7 @@
       </p:sp>
       <p:sp>
         <p:nvSpPr>
-          <p:cNvPr id="9" name="Isi kartu 1_44"/>
+          <p:cNvPr id="9" name="Isi kartu 1_50"/>
           <p:cNvSpPr txBox="1"/>
           <p:nvPr/>
         </p:nvSpPr>
@@ -3637,7 +3849,7 @@
       </p:sp>
       <p:sp>
         <p:nvSpPr>
-          <p:cNvPr id="10" name="Kartu_45"/>
+          <p:cNvPr id="10" name="Kartu_51"/>
           <p:cNvSpPr/>
           <p:nvPr/>
         </p:nvSpPr>
@@ -3666,7 +3878,7 @@
       </p:sp>
       <p:sp>
         <p:nvSpPr>
-          <p:cNvPr id="11" name="Penanda kartu_46"/>
+          <p:cNvPr id="11" name="Penanda kartu_52"/>
           <p:cNvSpPr/>
           <p:nvPr/>
         </p:nvSpPr>
@@ -3688,7 +3900,7 @@
       </p:sp>
       <p:sp>
         <p:nvSpPr>
-          <p:cNvPr id="12" name="Isi kartu 2_47"/>
+          <p:cNvPr id="12" name="Isi kartu 2_53"/>
           <p:cNvSpPr txBox="1"/>
           <p:nvPr/>
         </p:nvSpPr>
@@ -3743,7 +3955,7 @@
       </p:sp>
       <p:sp>
         <p:nvSpPr>
-          <p:cNvPr id="13" name="Kartu_48"/>
+          <p:cNvPr id="13" name="Kartu_54"/>
           <p:cNvSpPr/>
           <p:nvPr/>
         </p:nvSpPr>
@@ -3772,7 +3984,7 @@
       </p:sp>
       <p:sp>
         <p:nvSpPr>
-          <p:cNvPr id="14" name="Penanda kartu_49"/>
+          <p:cNvPr id="14" name="Penanda kartu_55"/>
           <p:cNvSpPr/>
           <p:nvPr/>
         </p:nvSpPr>
@@ -3794,7 +4006,7 @@
       </p:sp>
       <p:sp>
         <p:nvSpPr>
-          <p:cNvPr id="15" name="Isi kartu 3_50"/>
+          <p:cNvPr id="15" name="Isi kartu 3_56"/>
           <p:cNvSpPr txBox="1"/>
           <p:nvPr/>
         </p:nvSpPr>
@@ -3849,7 +4061,7 @@
       </p:sp>
       <p:sp>
         <p:nvSpPr>
-          <p:cNvPr id="16" name="Catatan bawah_51"/>
+          <p:cNvPr id="16" name="Catatan bawah_57"/>
           <p:cNvSpPr txBox="1"/>
           <p:nvPr/>
         </p:nvSpPr>
@@ -3885,7 +4097,7 @@
       </p:sp>
       <p:sp>
         <p:nvSpPr>
-          <p:cNvPr id="17" name="Tombol WhatsApp_52"/>
+          <p:cNvPr id="17" name="Tombol WhatsApp_58"/>
           <p:cNvSpPr/>
           <p:nvPr/>
         </p:nvSpPr>
@@ -4118,7 +4330,7 @@
       </p:grpSpPr>
       <p:pic>
         <p:nvPicPr>
-          <p:cNvPr id="2" name="Ikon_53" descr="Ikon highlight Cara Order">    </p:cNvPr>
+          <p:cNvPr id="2" name="Ikon_59" descr="Ikon highlight Cara Order">    </p:cNvPr>
           <p:cNvPicPr>
             <a:picLocks noChangeAspect="1"/>
           </p:cNvPicPr>
@@ -4263,7 +4475,7 @@
       </p:grpSpPr>
       <p:sp>
         <p:nvSpPr>
-          <p:cNvPr id="2" name="Latar judul_54"/>
+          <p:cNvPr id="2" name="Latar judul_60"/>
           <p:cNvSpPr/>
           <p:nvPr/>
         </p:nvSpPr>
@@ -4283,7 +4495,7 @@
       </p:sp>
       <p:sp>
         <p:nvSpPr>
-          <p:cNvPr id="3" name="Plat logo_55"/>
+          <p:cNvPr id="3" name="Plat logo_61"/>
           <p:cNvSpPr/>
           <p:nvPr/>
         </p:nvSpPr>
@@ -4305,7 +4517,7 @@
       </p:sp>
       <p:pic>
         <p:nvPicPr>
-          <p:cNvPr id="4" name="Logo H8KI_56" descr="Logo H8KI">    </p:cNvPr>
+          <p:cNvPr id="4" name="Logo H8KI_62" descr="Logo H8KI">    </p:cNvPr>
           <p:cNvPicPr>
             <a:picLocks noChangeAspect="1"/>
           </p:cNvPicPr>
@@ -4329,7 +4541,7 @@
       </p:pic>
       <p:sp>
         <p:nvSpPr>
-          <p:cNvPr id="5" name="Subjudul_57"/>
+          <p:cNvPr id="5" name="Subjudul_63"/>
           <p:cNvSpPr txBox="1"/>
           <p:nvPr/>
         </p:nvSpPr>
@@ -4365,7 +4577,7 @@
       </p:sp>
       <p:sp>
         <p:nvSpPr>
-          <p:cNvPr id="6" name="Judul_58"/>
+          <p:cNvPr id="6" name="Judul_64"/>
           <p:cNvSpPr txBox="1"/>
           <p:nvPr/>
         </p:nvSpPr>
@@ -4401,7 +4613,7 @@
       </p:sp>
       <p:sp>
         <p:nvSpPr>
-          <p:cNvPr id="7" name="Kartu_59"/>
+          <p:cNvPr id="7" name="Kartu_65"/>
           <p:cNvSpPr/>
           <p:nvPr/>
         </p:nvSpPr>
@@ -4430,7 +4642,7 @@
       </p:sp>
       <p:sp>
         <p:nvSpPr>
-          <p:cNvPr id="8" name="Penanda kartu_60"/>
+          <p:cNvPr id="8" name="Penanda kartu_66"/>
           <p:cNvSpPr/>
           <p:nvPr/>
         </p:nvSpPr>
@@ -4452,7 +4664,7 @@
       </p:sp>
       <p:sp>
         <p:nvSpPr>
-          <p:cNvPr id="9" name="Isi kartu 1_61"/>
+          <p:cNvPr id="9" name="Isi kartu 1_67"/>
           <p:cNvSpPr txBox="1"/>
           <p:nvPr/>
         </p:nvSpPr>
@@ -4507,7 +4719,7 @@
       </p:sp>
       <p:sp>
         <p:nvSpPr>
-          <p:cNvPr id="10" name="Kartu_62"/>
+          <p:cNvPr id="10" name="Kartu_68"/>
           <p:cNvSpPr/>
           <p:nvPr/>
         </p:nvSpPr>
@@ -4536,7 +4748,7 @@
       </p:sp>
       <p:sp>
         <p:nvSpPr>
-          <p:cNvPr id="11" name="Penanda kartu_63"/>
+          <p:cNvPr id="11" name="Penanda kartu_69"/>
           <p:cNvSpPr/>
           <p:nvPr/>
         </p:nvSpPr>
@@ -4558,7 +4770,7 @@
       </p:sp>
       <p:sp>
         <p:nvSpPr>
-          <p:cNvPr id="12" name="Isi kartu 2_64"/>
+          <p:cNvPr id="12" name="Isi kartu 2_70"/>
           <p:cNvSpPr txBox="1"/>
           <p:nvPr/>
         </p:nvSpPr>
@@ -4613,7 +4825,7 @@
       </p:sp>
       <p:sp>
         <p:nvSpPr>
-          <p:cNvPr id="13" name="Kartu_65"/>
+          <p:cNvPr id="13" name="Kartu_71"/>
           <p:cNvSpPr/>
           <p:nvPr/>
         </p:nvSpPr>
@@ -4642,7 +4854,7 @@
       </p:sp>
       <p:sp>
         <p:nvSpPr>
-          <p:cNvPr id="14" name="Penanda kartu_66"/>
+          <p:cNvPr id="14" name="Penanda kartu_72"/>
           <p:cNvSpPr/>
           <p:nvPr/>
         </p:nvSpPr>
@@ -4664,7 +4876,7 @@
       </p:sp>
       <p:sp>
         <p:nvSpPr>
-          <p:cNvPr id="15" name="Isi kartu 3_67"/>
+          <p:cNvPr id="15" name="Isi kartu 3_73"/>
           <p:cNvSpPr txBox="1"/>
           <p:nvPr/>
         </p:nvSpPr>
@@ -4719,7 +4931,7 @@
       </p:sp>
       <p:sp>
         <p:nvSpPr>
-          <p:cNvPr id="16" name="Kartu_68"/>
+          <p:cNvPr id="16" name="Kartu_74"/>
           <p:cNvSpPr/>
           <p:nvPr/>
         </p:nvSpPr>
@@ -4748,7 +4960,7 @@
       </p:sp>
       <p:sp>
         <p:nvSpPr>
-          <p:cNvPr id="17" name="Penanda kartu_69"/>
+          <p:cNvPr id="17" name="Penanda kartu_75"/>
           <p:cNvSpPr/>
           <p:nvPr/>
         </p:nvSpPr>
@@ -4770,7 +4982,7 @@
       </p:sp>
       <p:sp>
         <p:nvSpPr>
-          <p:cNvPr id="18" name="Isi kartu 4_70"/>
+          <p:cNvPr id="18" name="Isi kartu 4_76"/>
           <p:cNvSpPr txBox="1"/>
           <p:nvPr/>
         </p:nvSpPr>
@@ -4825,7 +5037,7 @@
       </p:sp>
       <p:sp>
         <p:nvSpPr>
-          <p:cNvPr id="19" name="Tombol WhatsApp_71"/>
+          <p:cNvPr id="19" name="Tombol WhatsApp_77"/>
           <p:cNvSpPr/>
           <p:nvPr/>
         </p:nvSpPr>
@@ -5076,7 +5288,7 @@
       </p:grpSpPr>
       <p:pic>
         <p:nvPicPr>
-          <p:cNvPr id="2" name="Ikon_72" descr="Ikon highlight Testimoni">    </p:cNvPr>
+          <p:cNvPr id="2" name="Ikon_78" descr="Ikon highlight Testimoni">    </p:cNvPr>
           <p:cNvPicPr>
             <a:picLocks noChangeAspect="1"/>
           </p:cNvPicPr>
@@ -5221,7 +5433,7 @@
       </p:grpSpPr>
       <p:sp>
         <p:nvSpPr>
-          <p:cNvPr id="2" name="Latar judul_73"/>
+          <p:cNvPr id="2" name="Latar judul_79"/>
           <p:cNvSpPr/>
           <p:nvPr/>
         </p:nvSpPr>
@@ -5241,7 +5453,7 @@
       </p:sp>
       <p:sp>
         <p:nvSpPr>
-          <p:cNvPr id="3" name="Plat logo_74"/>
+          <p:cNvPr id="3" name="Plat logo_80"/>
           <p:cNvSpPr/>
           <p:nvPr/>
         </p:nvSpPr>
@@ -5263,7 +5475,7 @@
       </p:sp>
       <p:pic>
         <p:nvPicPr>
-          <p:cNvPr id="4" name="Logo H8KI_75" descr="Logo H8KI">    </p:cNvPr>
+          <p:cNvPr id="4" name="Logo H8KI_81" descr="Logo H8KI">    </p:cNvPr>
           <p:cNvPicPr>
             <a:picLocks noChangeAspect="1"/>
           </p:cNvPicPr>
@@ -5287,7 +5499,7 @@
       </p:pic>
       <p:sp>
         <p:nvSpPr>
-          <p:cNvPr id="5" name="Subjudul_76"/>
+          <p:cNvPr id="5" name="Subjudul_82"/>
           <p:cNvSpPr txBox="1"/>
           <p:nvPr/>
         </p:nvSpPr>
@@ -5323,7 +5535,7 @@
       </p:sp>
       <p:sp>
         <p:nvSpPr>
-          <p:cNvPr id="6" name="Judul_77"/>
+          <p:cNvPr id="6" name="Judul_83"/>
           <p:cNvSpPr txBox="1"/>
           <p:nvPr/>
         </p:nvSpPr>
@@ -5359,7 +5571,7 @@
       </p:sp>
       <p:sp>
         <p:nvSpPr>
-          <p:cNvPr id="7" name="Kartu_78"/>
+          <p:cNvPr id="7" name="Kartu_84"/>
           <p:cNvSpPr/>
           <p:nvPr/>
         </p:nvSpPr>
@@ -5388,7 +5600,7 @@
       </p:sp>
       <p:sp>
         <p:nvSpPr>
-          <p:cNvPr id="8" name="Tanda kutip_79"/>
+          <p:cNvPr id="8" name="Tanda kutip_85"/>
           <p:cNvSpPr txBox="1"/>
           <p:nvPr/>
         </p:nvSpPr>
@@ -5424,7 +5636,7 @@
       </p:sp>
       <p:sp>
         <p:nvSpPr>
-          <p:cNvPr id="9" name="Kutipan_80"/>
+          <p:cNvPr id="9" name="Kutipan_86"/>
           <p:cNvSpPr txBox="1"/>
           <p:nvPr/>
         </p:nvSpPr>
@@ -5462,7 +5674,7 @@
       </p:sp>
       <p:sp>
         <p:nvSpPr>
-          <p:cNvPr id="10" name="Nama pelanggan_81"/>
+          <p:cNvPr id="10" name="Nama pelanggan_87"/>
           <p:cNvSpPr txBox="1"/>
           <p:nvPr/>
         </p:nvSpPr>
@@ -5498,7 +5710,7 @@
       </p:sp>
       <p:sp>
         <p:nvSpPr>
-          <p:cNvPr id="11" name="Bintang 1_82"/>
+          <p:cNvPr id="11" name="Bintang 1_88"/>
           <p:cNvSpPr/>
           <p:nvPr/>
         </p:nvSpPr>
@@ -5518,7 +5730,7 @@
       </p:sp>
       <p:sp>
         <p:nvSpPr>
-          <p:cNvPr id="12" name="Bintang 2_83"/>
+          <p:cNvPr id="12" name="Bintang 2_89"/>
           <p:cNvSpPr/>
           <p:nvPr/>
         </p:nvSpPr>
@@ -5538,7 +5750,7 @@
       </p:sp>
       <p:sp>
         <p:nvSpPr>
-          <p:cNvPr id="13" name="Bintang 3_84"/>
+          <p:cNvPr id="13" name="Bintang 3_90"/>
           <p:cNvSpPr/>
           <p:nvPr/>
         </p:nvSpPr>
@@ -5558,7 +5770,7 @@
       </p:sp>
       <p:sp>
         <p:nvSpPr>
-          <p:cNvPr id="14" name="Bintang 4_85"/>
+          <p:cNvPr id="14" name="Bintang 4_91"/>
           <p:cNvSpPr/>
           <p:nvPr/>
         </p:nvSpPr>
@@ -5578,7 +5790,7 @@
       </p:sp>
       <p:sp>
         <p:nvSpPr>
-          <p:cNvPr id="15" name="Bintang 5_86"/>
+          <p:cNvPr id="15" name="Bintang 5_92"/>
           <p:cNvSpPr/>
           <p:nvPr/>
         </p:nvSpPr>
@@ -5598,7 +5810,7 @@
       </p:sp>
       <p:sp>
         <p:nvSpPr>
-          <p:cNvPr id="16" name="Tombol WhatsApp_87"/>
+          <p:cNvPr id="16" name="Tombol WhatsApp_93"/>
           <p:cNvSpPr/>
           <p:nvPr/>
         </p:nvSpPr>

</xml_diff>